<commit_message>
Actualizar presentaciones: preview_walmart y día 2 Módulo 4
Co-Authored-By: Claude Opus 4.6 (1M context) <noreply@anthropic.com>
</commit_message>
<xml_diff>
--- a/docs/slides/Modulo 3/preview_walmart.pptx
+++ b/docs/slides/Modulo 3/preview_walmart.pptx
@@ -5,17 +5,17 @@
     <p:sldMasterId id="2147483648" r:id="rId1"/>
   </p:sldMasterIdLst>
   <p:sldIdLst>
-    <p:sldId id="256" r:id="rId7"/>
-    <p:sldId id="257" r:id="rId8"/>
-    <p:sldId id="258" r:id="rId9"/>
-    <p:sldId id="259" r:id="rId10"/>
-    <p:sldId id="260" r:id="rId11"/>
-    <p:sldId id="261" r:id="rId12"/>
-    <p:sldId id="262" r:id="rId13"/>
-    <p:sldId id="263" r:id="rId14"/>
-    <p:sldId id="264" r:id="rId15"/>
+    <p:sldId id="256" r:id="rId2"/>
+    <p:sldId id="257" r:id="rId3"/>
+    <p:sldId id="258" r:id="rId4"/>
+    <p:sldId id="259" r:id="rId5"/>
+    <p:sldId id="260" r:id="rId6"/>
+    <p:sldId id="261" r:id="rId7"/>
+    <p:sldId id="262" r:id="rId8"/>
+    <p:sldId id="263" r:id="rId9"/>
+    <p:sldId id="264" r:id="rId10"/>
   </p:sldIdLst>
-  <p:sldSz cx="12188952" cy="6858000" type="screen4x3"/>
+  <p:sldSz cx="12188825" cy="6858000"/>
   <p:notesSz cx="6858000" cy="9144000"/>
   <p:defaultTextStyle>
     <a:defPPr>
@@ -112,6 +112,22 @@
       </a:defRPr>
     </a:lvl9pPr>
   </p:defaultTextStyle>
+  <p:extLst>
+    <p:ext uri="{EFAFB233-063F-42B5-8137-9DF3F51BA10A}">
+      <p15:sldGuideLst xmlns:p15="http://schemas.microsoft.com/office/powerpoint/2012/main">
+        <p15:guide id="1" orient="horz" pos="2160">
+          <p15:clr>
+            <a:srgbClr val="A4A3A4"/>
+          </p15:clr>
+        </p15:guide>
+        <p15:guide id="2" pos="2880">
+          <p15:clr>
+            <a:srgbClr val="A4A3A4"/>
+          </p15:clr>
+        </p15:guide>
+      </p15:sldGuideLst>
+    </p:ext>
+  </p:extLst>
 </p:presentation>
 </file>
 
@@ -153,10 +169,9 @@
           <a:lstStyle/>
           <a:p>
             <a:r>
-              <a:rPr lang="en-US" smtClean="0"/>
+              <a:rPr lang="en-US"/>
               <a:t>Click to edit Master title style</a:t>
             </a:r>
-            <a:endParaRPr lang="en-US"/>
           </a:p>
         </p:txBody>
       </p:sp>
@@ -272,10 +287,9 @@
           </a:lstStyle>
           <a:p>
             <a:r>
-              <a:rPr lang="en-US" smtClean="0"/>
+              <a:rPr lang="en-US"/>
               <a:t>Click to edit Master subtitle style</a:t>
             </a:r>
-            <a:endParaRPr lang="en-US"/>
           </a:p>
         </p:txBody>
       </p:sp>
@@ -296,7 +310,7 @@
           <a:p>
             <a:fld id="{5BCAD085-E8A6-8845-BD4E-CB4CCA059FC4}" type="datetimeFigureOut">
               <a:rPr lang="en-US" smtClean="0"/>
-              <a:t>1/27/13</a:t>
+              <a:t>4/22/2026</a:t>
             </a:fld>
             <a:endParaRPr lang="en-US"/>
           </a:p>
@@ -338,7 +352,7 @@
           <a:p>
             <a:fld id="{C1FF6DA9-008F-8B48-92A6-B652298478BF}" type="slidenum">
               <a:rPr lang="en-US" smtClean="0"/>
-              <a:t>‹#›</a:t>
+              <a:t>‹Nº›</a:t>
             </a:fld>
             <a:endParaRPr lang="en-US"/>
           </a:p>
@@ -390,10 +404,9 @@
           <a:lstStyle/>
           <a:p>
             <a:r>
-              <a:rPr lang="en-US" smtClean="0"/>
+              <a:rPr lang="en-US"/>
               <a:t>Click to edit Master title style</a:t>
             </a:r>
-            <a:endParaRPr lang="en-US"/>
           </a:p>
         </p:txBody>
       </p:sp>
@@ -414,38 +427,37 @@
           <a:p>
             <a:pPr lvl="0"/>
             <a:r>
-              <a:rPr lang="en-US" smtClean="0"/>
+              <a:rPr lang="en-US"/>
               <a:t>Click to edit Master text styles</a:t>
             </a:r>
           </a:p>
           <a:p>
             <a:pPr lvl="1"/>
             <a:r>
-              <a:rPr lang="en-US" smtClean="0"/>
+              <a:rPr lang="en-US"/>
               <a:t>Second level</a:t>
             </a:r>
           </a:p>
           <a:p>
             <a:pPr lvl="2"/>
             <a:r>
-              <a:rPr lang="en-US" smtClean="0"/>
+              <a:rPr lang="en-US"/>
               <a:t>Third level</a:t>
             </a:r>
           </a:p>
           <a:p>
             <a:pPr lvl="3"/>
             <a:r>
-              <a:rPr lang="en-US" smtClean="0"/>
+              <a:rPr lang="en-US"/>
               <a:t>Fourth level</a:t>
             </a:r>
           </a:p>
           <a:p>
             <a:pPr lvl="4"/>
             <a:r>
-              <a:rPr lang="en-US" smtClean="0"/>
+              <a:rPr lang="en-US"/>
               <a:t>Fifth level</a:t>
             </a:r>
-            <a:endParaRPr lang="en-US"/>
           </a:p>
         </p:txBody>
       </p:sp>
@@ -466,7 +478,7 @@
           <a:p>
             <a:fld id="{5BCAD085-E8A6-8845-BD4E-CB4CCA059FC4}" type="datetimeFigureOut">
               <a:rPr lang="en-US" smtClean="0"/>
-              <a:t>1/27/13</a:t>
+              <a:t>4/22/2026</a:t>
             </a:fld>
             <a:endParaRPr lang="en-US"/>
           </a:p>
@@ -508,7 +520,7 @@
           <a:p>
             <a:fld id="{C1FF6DA9-008F-8B48-92A6-B652298478BF}" type="slidenum">
               <a:rPr lang="en-US" smtClean="0"/>
-              <a:t>‹#›</a:t>
+              <a:t>‹Nº›</a:t>
             </a:fld>
             <a:endParaRPr lang="en-US"/>
           </a:p>
@@ -565,10 +577,9 @@
           <a:lstStyle/>
           <a:p>
             <a:r>
-              <a:rPr lang="en-US" smtClean="0"/>
+              <a:rPr lang="en-US"/>
               <a:t>Click to edit Master title style</a:t>
             </a:r>
-            <a:endParaRPr lang="en-US"/>
           </a:p>
         </p:txBody>
       </p:sp>
@@ -594,38 +605,37 @@
           <a:p>
             <a:pPr lvl="0"/>
             <a:r>
-              <a:rPr lang="en-US" smtClean="0"/>
+              <a:rPr lang="en-US"/>
               <a:t>Click to edit Master text styles</a:t>
             </a:r>
           </a:p>
           <a:p>
             <a:pPr lvl="1"/>
             <a:r>
-              <a:rPr lang="en-US" smtClean="0"/>
+              <a:rPr lang="en-US"/>
               <a:t>Second level</a:t>
             </a:r>
           </a:p>
           <a:p>
             <a:pPr lvl="2"/>
             <a:r>
-              <a:rPr lang="en-US" smtClean="0"/>
+              <a:rPr lang="en-US"/>
               <a:t>Third level</a:t>
             </a:r>
           </a:p>
           <a:p>
             <a:pPr lvl="3"/>
             <a:r>
-              <a:rPr lang="en-US" smtClean="0"/>
+              <a:rPr lang="en-US"/>
               <a:t>Fourth level</a:t>
             </a:r>
           </a:p>
           <a:p>
             <a:pPr lvl="4"/>
             <a:r>
-              <a:rPr lang="en-US" smtClean="0"/>
+              <a:rPr lang="en-US"/>
               <a:t>Fifth level</a:t>
             </a:r>
-            <a:endParaRPr lang="en-US"/>
           </a:p>
         </p:txBody>
       </p:sp>
@@ -646,7 +656,7 @@
           <a:p>
             <a:fld id="{5BCAD085-E8A6-8845-BD4E-CB4CCA059FC4}" type="datetimeFigureOut">
               <a:rPr lang="en-US" smtClean="0"/>
-              <a:t>1/27/13</a:t>
+              <a:t>4/22/2026</a:t>
             </a:fld>
             <a:endParaRPr lang="en-US"/>
           </a:p>
@@ -688,7 +698,7 @@
           <a:p>
             <a:fld id="{C1FF6DA9-008F-8B48-92A6-B652298478BF}" type="slidenum">
               <a:rPr lang="en-US" smtClean="0"/>
-              <a:t>‹#›</a:t>
+              <a:t>‹Nº›</a:t>
             </a:fld>
             <a:endParaRPr lang="en-US"/>
           </a:p>
@@ -740,10 +750,9 @@
           <a:lstStyle/>
           <a:p>
             <a:r>
-              <a:rPr lang="en-US" smtClean="0"/>
+              <a:rPr lang="en-US"/>
               <a:t>Click to edit Master title style</a:t>
             </a:r>
-            <a:endParaRPr lang="en-US"/>
           </a:p>
         </p:txBody>
       </p:sp>
@@ -764,38 +773,37 @@
           <a:p>
             <a:pPr lvl="0"/>
             <a:r>
-              <a:rPr lang="en-US" smtClean="0"/>
+              <a:rPr lang="en-US"/>
               <a:t>Click to edit Master text styles</a:t>
             </a:r>
           </a:p>
           <a:p>
             <a:pPr lvl="1"/>
             <a:r>
-              <a:rPr lang="en-US" smtClean="0"/>
+              <a:rPr lang="en-US"/>
               <a:t>Second level</a:t>
             </a:r>
           </a:p>
           <a:p>
             <a:pPr lvl="2"/>
             <a:r>
-              <a:rPr lang="en-US" smtClean="0"/>
+              <a:rPr lang="en-US"/>
               <a:t>Third level</a:t>
             </a:r>
           </a:p>
           <a:p>
             <a:pPr lvl="3"/>
             <a:r>
-              <a:rPr lang="en-US" smtClean="0"/>
+              <a:rPr lang="en-US"/>
               <a:t>Fourth level</a:t>
             </a:r>
           </a:p>
           <a:p>
             <a:pPr lvl="4"/>
             <a:r>
-              <a:rPr lang="en-US" smtClean="0"/>
+              <a:rPr lang="en-US"/>
               <a:t>Fifth level</a:t>
             </a:r>
-            <a:endParaRPr lang="en-US"/>
           </a:p>
         </p:txBody>
       </p:sp>
@@ -816,7 +824,7 @@
           <a:p>
             <a:fld id="{5BCAD085-E8A6-8845-BD4E-CB4CCA059FC4}" type="datetimeFigureOut">
               <a:rPr lang="en-US" smtClean="0"/>
-              <a:t>1/27/13</a:t>
+              <a:t>4/22/2026</a:t>
             </a:fld>
             <a:endParaRPr lang="en-US"/>
           </a:p>
@@ -858,7 +866,7 @@
           <a:p>
             <a:fld id="{C1FF6DA9-008F-8B48-92A6-B652298478BF}" type="slidenum">
               <a:rPr lang="en-US" smtClean="0"/>
-              <a:t>‹#›</a:t>
+              <a:t>‹Nº›</a:t>
             </a:fld>
             <a:endParaRPr lang="en-US"/>
           </a:p>
@@ -919,10 +927,9 @@
           </a:lstStyle>
           <a:p>
             <a:r>
-              <a:rPr lang="en-US" smtClean="0"/>
+              <a:rPr lang="en-US"/>
               <a:t>Click to edit Master title style</a:t>
             </a:r>
-            <a:endParaRPr lang="en-US"/>
           </a:p>
         </p:txBody>
       </p:sp>
@@ -1039,7 +1046,7 @@
           <a:p>
             <a:pPr lvl="0"/>
             <a:r>
-              <a:rPr lang="en-US" smtClean="0"/>
+              <a:rPr lang="en-US"/>
               <a:t>Click to edit Master text styles</a:t>
             </a:r>
           </a:p>
@@ -1062,7 +1069,7 @@
           <a:p>
             <a:fld id="{5BCAD085-E8A6-8845-BD4E-CB4CCA059FC4}" type="datetimeFigureOut">
               <a:rPr lang="en-US" smtClean="0"/>
-              <a:t>1/27/13</a:t>
+              <a:t>4/22/2026</a:t>
             </a:fld>
             <a:endParaRPr lang="en-US"/>
           </a:p>
@@ -1104,7 +1111,7 @@
           <a:p>
             <a:fld id="{C1FF6DA9-008F-8B48-92A6-B652298478BF}" type="slidenum">
               <a:rPr lang="en-US" smtClean="0"/>
-              <a:t>‹#›</a:t>
+              <a:t>‹Nº›</a:t>
             </a:fld>
             <a:endParaRPr lang="en-US"/>
           </a:p>
@@ -1156,10 +1163,9 @@
           <a:lstStyle/>
           <a:p>
             <a:r>
-              <a:rPr lang="en-US" smtClean="0"/>
+              <a:rPr lang="en-US"/>
               <a:t>Click to edit Master title style</a:t>
             </a:r>
-            <a:endParaRPr lang="en-US"/>
           </a:p>
         </p:txBody>
       </p:sp>
@@ -1213,38 +1219,37 @@
           <a:p>
             <a:pPr lvl="0"/>
             <a:r>
-              <a:rPr lang="en-US" smtClean="0"/>
+              <a:rPr lang="en-US"/>
               <a:t>Click to edit Master text styles</a:t>
             </a:r>
           </a:p>
           <a:p>
             <a:pPr lvl="1"/>
             <a:r>
-              <a:rPr lang="en-US" smtClean="0"/>
+              <a:rPr lang="en-US"/>
               <a:t>Second level</a:t>
             </a:r>
           </a:p>
           <a:p>
             <a:pPr lvl="2"/>
             <a:r>
-              <a:rPr lang="en-US" smtClean="0"/>
+              <a:rPr lang="en-US"/>
               <a:t>Third level</a:t>
             </a:r>
           </a:p>
           <a:p>
             <a:pPr lvl="3"/>
             <a:r>
-              <a:rPr lang="en-US" smtClean="0"/>
+              <a:rPr lang="en-US"/>
               <a:t>Fourth level</a:t>
             </a:r>
           </a:p>
           <a:p>
             <a:pPr lvl="4"/>
             <a:r>
-              <a:rPr lang="en-US" smtClean="0"/>
+              <a:rPr lang="en-US"/>
               <a:t>Fifth level</a:t>
             </a:r>
-            <a:endParaRPr lang="en-US"/>
           </a:p>
         </p:txBody>
       </p:sp>
@@ -1298,38 +1303,37 @@
           <a:p>
             <a:pPr lvl="0"/>
             <a:r>
-              <a:rPr lang="en-US" smtClean="0"/>
+              <a:rPr lang="en-US"/>
               <a:t>Click to edit Master text styles</a:t>
             </a:r>
           </a:p>
           <a:p>
             <a:pPr lvl="1"/>
             <a:r>
-              <a:rPr lang="en-US" smtClean="0"/>
+              <a:rPr lang="en-US"/>
               <a:t>Second level</a:t>
             </a:r>
           </a:p>
           <a:p>
             <a:pPr lvl="2"/>
             <a:r>
-              <a:rPr lang="en-US" smtClean="0"/>
+              <a:rPr lang="en-US"/>
               <a:t>Third level</a:t>
             </a:r>
           </a:p>
           <a:p>
             <a:pPr lvl="3"/>
             <a:r>
-              <a:rPr lang="en-US" smtClean="0"/>
+              <a:rPr lang="en-US"/>
               <a:t>Fourth level</a:t>
             </a:r>
           </a:p>
           <a:p>
             <a:pPr lvl="4"/>
             <a:r>
-              <a:rPr lang="en-US" smtClean="0"/>
+              <a:rPr lang="en-US"/>
               <a:t>Fifth level</a:t>
             </a:r>
-            <a:endParaRPr lang="en-US"/>
           </a:p>
         </p:txBody>
       </p:sp>
@@ -1350,7 +1354,7 @@
           <a:p>
             <a:fld id="{5BCAD085-E8A6-8845-BD4E-CB4CCA059FC4}" type="datetimeFigureOut">
               <a:rPr lang="en-US" smtClean="0"/>
-              <a:t>1/27/13</a:t>
+              <a:t>4/22/2026</a:t>
             </a:fld>
             <a:endParaRPr lang="en-US"/>
           </a:p>
@@ -1392,7 +1396,7 @@
           <a:p>
             <a:fld id="{C1FF6DA9-008F-8B48-92A6-B652298478BF}" type="slidenum">
               <a:rPr lang="en-US" smtClean="0"/>
-              <a:t>‹#›</a:t>
+              <a:t>‹Nº›</a:t>
             </a:fld>
             <a:endParaRPr lang="en-US"/>
           </a:p>
@@ -1448,10 +1452,9 @@
           </a:lstStyle>
           <a:p>
             <a:r>
-              <a:rPr lang="en-US" smtClean="0"/>
+              <a:rPr lang="en-US"/>
               <a:t>Click to edit Master title style</a:t>
             </a:r>
-            <a:endParaRPr lang="en-US"/>
           </a:p>
         </p:txBody>
       </p:sp>
@@ -1514,7 +1517,7 @@
           <a:p>
             <a:pPr lvl="0"/>
             <a:r>
-              <a:rPr lang="en-US" smtClean="0"/>
+              <a:rPr lang="en-US"/>
               <a:t>Click to edit Master text styles</a:t>
             </a:r>
           </a:p>
@@ -1570,38 +1573,37 @@
           <a:p>
             <a:pPr lvl="0"/>
             <a:r>
-              <a:rPr lang="en-US" smtClean="0"/>
+              <a:rPr lang="en-US"/>
               <a:t>Click to edit Master text styles</a:t>
             </a:r>
           </a:p>
           <a:p>
             <a:pPr lvl="1"/>
             <a:r>
-              <a:rPr lang="en-US" smtClean="0"/>
+              <a:rPr lang="en-US"/>
               <a:t>Second level</a:t>
             </a:r>
           </a:p>
           <a:p>
             <a:pPr lvl="2"/>
             <a:r>
-              <a:rPr lang="en-US" smtClean="0"/>
+              <a:rPr lang="en-US"/>
               <a:t>Third level</a:t>
             </a:r>
           </a:p>
           <a:p>
             <a:pPr lvl="3"/>
             <a:r>
-              <a:rPr lang="en-US" smtClean="0"/>
+              <a:rPr lang="en-US"/>
               <a:t>Fourth level</a:t>
             </a:r>
           </a:p>
           <a:p>
             <a:pPr lvl="4"/>
             <a:r>
-              <a:rPr lang="en-US" smtClean="0"/>
+              <a:rPr lang="en-US"/>
               <a:t>Fifth level</a:t>
             </a:r>
-            <a:endParaRPr lang="en-US"/>
           </a:p>
         </p:txBody>
       </p:sp>
@@ -1664,7 +1666,7 @@
           <a:p>
             <a:pPr lvl="0"/>
             <a:r>
-              <a:rPr lang="en-US" smtClean="0"/>
+              <a:rPr lang="en-US"/>
               <a:t>Click to edit Master text styles</a:t>
             </a:r>
           </a:p>
@@ -1720,38 +1722,37 @@
           <a:p>
             <a:pPr lvl="0"/>
             <a:r>
-              <a:rPr lang="en-US" smtClean="0"/>
+              <a:rPr lang="en-US"/>
               <a:t>Click to edit Master text styles</a:t>
             </a:r>
           </a:p>
           <a:p>
             <a:pPr lvl="1"/>
             <a:r>
-              <a:rPr lang="en-US" smtClean="0"/>
+              <a:rPr lang="en-US"/>
               <a:t>Second level</a:t>
             </a:r>
           </a:p>
           <a:p>
             <a:pPr lvl="2"/>
             <a:r>
-              <a:rPr lang="en-US" smtClean="0"/>
+              <a:rPr lang="en-US"/>
               <a:t>Third level</a:t>
             </a:r>
           </a:p>
           <a:p>
             <a:pPr lvl="3"/>
             <a:r>
-              <a:rPr lang="en-US" smtClean="0"/>
+              <a:rPr lang="en-US"/>
               <a:t>Fourth level</a:t>
             </a:r>
           </a:p>
           <a:p>
             <a:pPr lvl="4"/>
             <a:r>
-              <a:rPr lang="en-US" smtClean="0"/>
+              <a:rPr lang="en-US"/>
               <a:t>Fifth level</a:t>
             </a:r>
-            <a:endParaRPr lang="en-US"/>
           </a:p>
         </p:txBody>
       </p:sp>
@@ -1772,7 +1773,7 @@
           <a:p>
             <a:fld id="{5BCAD085-E8A6-8845-BD4E-CB4CCA059FC4}" type="datetimeFigureOut">
               <a:rPr lang="en-US" smtClean="0"/>
-              <a:t>1/27/13</a:t>
+              <a:t>4/22/2026</a:t>
             </a:fld>
             <a:endParaRPr lang="en-US"/>
           </a:p>
@@ -1814,7 +1815,7 @@
           <a:p>
             <a:fld id="{C1FF6DA9-008F-8B48-92A6-B652298478BF}" type="slidenum">
               <a:rPr lang="en-US" smtClean="0"/>
-              <a:t>‹#›</a:t>
+              <a:t>‹Nº›</a:t>
             </a:fld>
             <a:endParaRPr lang="en-US"/>
           </a:p>
@@ -1866,10 +1867,9 @@
           <a:lstStyle/>
           <a:p>
             <a:r>
-              <a:rPr lang="en-US" smtClean="0"/>
+              <a:rPr lang="en-US"/>
               <a:t>Click to edit Master title style</a:t>
             </a:r>
-            <a:endParaRPr lang="en-US"/>
           </a:p>
         </p:txBody>
       </p:sp>
@@ -1890,7 +1890,7 @@
           <a:p>
             <a:fld id="{5BCAD085-E8A6-8845-BD4E-CB4CCA059FC4}" type="datetimeFigureOut">
               <a:rPr lang="en-US" smtClean="0"/>
-              <a:t>1/27/13</a:t>
+              <a:t>4/22/2026</a:t>
             </a:fld>
             <a:endParaRPr lang="en-US"/>
           </a:p>
@@ -1932,7 +1932,7 @@
           <a:p>
             <a:fld id="{C1FF6DA9-008F-8B48-92A6-B652298478BF}" type="slidenum">
               <a:rPr lang="en-US" smtClean="0"/>
-              <a:t>‹#›</a:t>
+              <a:t>‹Nº›</a:t>
             </a:fld>
             <a:endParaRPr lang="en-US"/>
           </a:p>
@@ -1985,7 +1985,7 @@
           <a:p>
             <a:fld id="{5BCAD085-E8A6-8845-BD4E-CB4CCA059FC4}" type="datetimeFigureOut">
               <a:rPr lang="en-US" smtClean="0"/>
-              <a:t>1/27/13</a:t>
+              <a:t>4/22/2026</a:t>
             </a:fld>
             <a:endParaRPr lang="en-US"/>
           </a:p>
@@ -2027,7 +2027,7 @@
           <a:p>
             <a:fld id="{C1FF6DA9-008F-8B48-92A6-B652298478BF}" type="slidenum">
               <a:rPr lang="en-US" smtClean="0"/>
-              <a:t>‹#›</a:t>
+              <a:t>‹Nº›</a:t>
             </a:fld>
             <a:endParaRPr lang="en-US"/>
           </a:p>
@@ -2088,10 +2088,9 @@
           </a:lstStyle>
           <a:p>
             <a:r>
-              <a:rPr lang="en-US" smtClean="0"/>
+              <a:rPr lang="en-US"/>
               <a:t>Click to edit Master title style</a:t>
             </a:r>
-            <a:endParaRPr lang="en-US"/>
           </a:p>
         </p:txBody>
       </p:sp>
@@ -2145,38 +2144,37 @@
           <a:p>
             <a:pPr lvl="0"/>
             <a:r>
-              <a:rPr lang="en-US" smtClean="0"/>
+              <a:rPr lang="en-US"/>
               <a:t>Click to edit Master text styles</a:t>
             </a:r>
           </a:p>
           <a:p>
             <a:pPr lvl="1"/>
             <a:r>
-              <a:rPr lang="en-US" smtClean="0"/>
+              <a:rPr lang="en-US"/>
               <a:t>Second level</a:t>
             </a:r>
           </a:p>
           <a:p>
             <a:pPr lvl="2"/>
             <a:r>
-              <a:rPr lang="en-US" smtClean="0"/>
+              <a:rPr lang="en-US"/>
               <a:t>Third level</a:t>
             </a:r>
           </a:p>
           <a:p>
             <a:pPr lvl="3"/>
             <a:r>
-              <a:rPr lang="en-US" smtClean="0"/>
+              <a:rPr lang="en-US"/>
               <a:t>Fourth level</a:t>
             </a:r>
           </a:p>
           <a:p>
             <a:pPr lvl="4"/>
             <a:r>
-              <a:rPr lang="en-US" smtClean="0"/>
+              <a:rPr lang="en-US"/>
               <a:t>Fifth level</a:t>
             </a:r>
-            <a:endParaRPr lang="en-US"/>
           </a:p>
         </p:txBody>
       </p:sp>
@@ -2239,7 +2237,7 @@
           <a:p>
             <a:pPr lvl="0"/>
             <a:r>
-              <a:rPr lang="en-US" smtClean="0"/>
+              <a:rPr lang="en-US"/>
               <a:t>Click to edit Master text styles</a:t>
             </a:r>
           </a:p>
@@ -2262,7 +2260,7 @@
           <a:p>
             <a:fld id="{5BCAD085-E8A6-8845-BD4E-CB4CCA059FC4}" type="datetimeFigureOut">
               <a:rPr lang="en-US" smtClean="0"/>
-              <a:t>1/27/13</a:t>
+              <a:t>4/22/2026</a:t>
             </a:fld>
             <a:endParaRPr lang="en-US"/>
           </a:p>
@@ -2304,7 +2302,7 @@
           <a:p>
             <a:fld id="{C1FF6DA9-008F-8B48-92A6-B652298478BF}" type="slidenum">
               <a:rPr lang="en-US" smtClean="0"/>
-              <a:t>‹#›</a:t>
+              <a:t>‹Nº›</a:t>
             </a:fld>
             <a:endParaRPr lang="en-US"/>
           </a:p>
@@ -2365,10 +2363,9 @@
           </a:lstStyle>
           <a:p>
             <a:r>
-              <a:rPr lang="en-US" smtClean="0"/>
+              <a:rPr lang="en-US"/>
               <a:t>Click to edit Master title style</a:t>
             </a:r>
-            <a:endParaRPr lang="en-US"/>
           </a:p>
         </p:txBody>
       </p:sp>
@@ -2492,7 +2489,7 @@
           <a:p>
             <a:pPr lvl="0"/>
             <a:r>
-              <a:rPr lang="en-US" smtClean="0"/>
+              <a:rPr lang="en-US"/>
               <a:t>Click to edit Master text styles</a:t>
             </a:r>
           </a:p>
@@ -2515,7 +2512,7 @@
           <a:p>
             <a:fld id="{5BCAD085-E8A6-8845-BD4E-CB4CCA059FC4}" type="datetimeFigureOut">
               <a:rPr lang="en-US" smtClean="0"/>
-              <a:t>1/27/13</a:t>
+              <a:t>4/22/2026</a:t>
             </a:fld>
             <a:endParaRPr lang="en-US"/>
           </a:p>
@@ -2557,7 +2554,7 @@
           <a:p>
             <a:fld id="{C1FF6DA9-008F-8B48-92A6-B652298478BF}" type="slidenum">
               <a:rPr lang="en-US" smtClean="0"/>
-              <a:t>‹#›</a:t>
+              <a:t>‹Nº›</a:t>
             </a:fld>
             <a:endParaRPr lang="en-US"/>
           </a:p>
@@ -2624,10 +2621,9 @@
           <a:lstStyle/>
           <a:p>
             <a:r>
-              <a:rPr lang="en-US" smtClean="0"/>
+              <a:rPr lang="en-US"/>
               <a:t>Click to edit Master title style</a:t>
             </a:r>
-            <a:endParaRPr lang="en-US"/>
           </a:p>
         </p:txBody>
       </p:sp>
@@ -2658,38 +2654,37 @@
           <a:p>
             <a:pPr lvl="0"/>
             <a:r>
-              <a:rPr lang="en-US" smtClean="0"/>
+              <a:rPr lang="en-US"/>
               <a:t>Click to edit Master text styles</a:t>
             </a:r>
           </a:p>
           <a:p>
             <a:pPr lvl="1"/>
             <a:r>
-              <a:rPr lang="en-US" smtClean="0"/>
+              <a:rPr lang="en-US"/>
               <a:t>Second level</a:t>
             </a:r>
           </a:p>
           <a:p>
             <a:pPr lvl="2"/>
             <a:r>
-              <a:rPr lang="en-US" smtClean="0"/>
+              <a:rPr lang="en-US"/>
               <a:t>Third level</a:t>
             </a:r>
           </a:p>
           <a:p>
             <a:pPr lvl="3"/>
             <a:r>
-              <a:rPr lang="en-US" smtClean="0"/>
+              <a:rPr lang="en-US"/>
               <a:t>Fourth level</a:t>
             </a:r>
           </a:p>
           <a:p>
             <a:pPr lvl="4"/>
             <a:r>
-              <a:rPr lang="en-US" smtClean="0"/>
+              <a:rPr lang="en-US"/>
               <a:t>Fifth level</a:t>
             </a:r>
-            <a:endParaRPr lang="en-US"/>
           </a:p>
         </p:txBody>
       </p:sp>
@@ -2728,7 +2723,7 @@
           <a:p>
             <a:fld id="{5BCAD085-E8A6-8845-BD4E-CB4CCA059FC4}" type="datetimeFigureOut">
               <a:rPr lang="en-US" smtClean="0"/>
-              <a:t>1/27/13</a:t>
+              <a:t>4/22/2026</a:t>
             </a:fld>
             <a:endParaRPr lang="en-US"/>
           </a:p>
@@ -2806,7 +2801,7 @@
           <a:p>
             <a:fld id="{C1FF6DA9-008F-8B48-92A6-B652298478BF}" type="slidenum">
               <a:rPr lang="en-US" smtClean="0"/>
-              <a:t>‹#›</a:t>
+              <a:t>‹Nº›</a:t>
             </a:fld>
             <a:endParaRPr lang="en-US"/>
           </a:p>
@@ -3087,7 +3082,7 @@
 </file>
 
 <file path=ppt/slides/slide1.xml><?xml version="1.0" encoding="utf-8"?>
-<p:sld xmlns:a="http://schemas.openxmlformats.org/drawingml/2006/main" xmlns:p="http://schemas.openxmlformats.org/presentationml/2006/main" xmlns:r="http://schemas.openxmlformats.org/officeDocument/2006/relationships">
+<p:sld xmlns:a="http://schemas.openxmlformats.org/drawingml/2006/main" xmlns:r="http://schemas.openxmlformats.org/officeDocument/2006/relationships" xmlns:p="http://schemas.openxmlformats.org/presentationml/2006/main">
   <p:cSld>
     <p:spTree>
       <p:nvGrpSpPr>
@@ -3095,7 +3090,14 @@
         <p:cNvGrpSpPr/>
         <p:nvPr/>
       </p:nvGrpSpPr>
-      <p:grpSpPr/>
+      <p:grpSpPr>
+        <a:xfrm>
+          <a:off x="0" y="0"/>
+          <a:ext cx="0" cy="0"/>
+          <a:chOff x="0" y="0"/>
+          <a:chExt cx="0" cy="0"/>
+        </a:xfrm>
+      </p:grpSpPr>
       <p:sp>
         <p:nvSpPr>
           <p:cNvPr id="2" name="Rectangle 1"/>
@@ -3136,6 +3138,7 @@
           <a:lstStyle/>
           <a:p>
             <a:pPr algn="ctr"/>
+            <a:endParaRPr/>
           </a:p>
         </p:txBody>
       </p:sp>
@@ -3179,6 +3182,7 @@
           <a:lstStyle/>
           <a:p>
             <a:pPr algn="ctr"/>
+            <a:endParaRPr/>
           </a:p>
         </p:txBody>
       </p:sp>
@@ -3297,7 +3301,7 @@
 </file>
 
 <file path=ppt/slides/slide2.xml><?xml version="1.0" encoding="utf-8"?>
-<p:sld xmlns:a="http://schemas.openxmlformats.org/drawingml/2006/main" xmlns:p="http://schemas.openxmlformats.org/presentationml/2006/main" xmlns:r="http://schemas.openxmlformats.org/officeDocument/2006/relationships">
+<p:sld xmlns:a="http://schemas.openxmlformats.org/drawingml/2006/main" xmlns:r="http://schemas.openxmlformats.org/officeDocument/2006/relationships" xmlns:p="http://schemas.openxmlformats.org/presentationml/2006/main">
   <p:cSld>
     <p:spTree>
       <p:nvGrpSpPr>
@@ -3305,7 +3309,14 @@
         <p:cNvGrpSpPr/>
         <p:nvPr/>
       </p:nvGrpSpPr>
-      <p:grpSpPr/>
+      <p:grpSpPr>
+        <a:xfrm>
+          <a:off x="0" y="0"/>
+          <a:ext cx="0" cy="0"/>
+          <a:chOff x="0" y="0"/>
+          <a:chExt cx="0" cy="0"/>
+        </a:xfrm>
+      </p:grpSpPr>
       <p:sp>
         <p:nvSpPr>
           <p:cNvPr id="2" name="Rectangle 1"/>
@@ -3346,6 +3357,7 @@
           <a:lstStyle/>
           <a:p>
             <a:pPr algn="ctr"/>
+            <a:endParaRPr/>
           </a:p>
         </p:txBody>
       </p:sp>
@@ -3426,7 +3438,7 @@
 </file>
 
 <file path=ppt/slides/slide3.xml><?xml version="1.0" encoding="utf-8"?>
-<p:sld xmlns:a="http://schemas.openxmlformats.org/drawingml/2006/main" xmlns:p="http://schemas.openxmlformats.org/presentationml/2006/main" xmlns:r="http://schemas.openxmlformats.org/officeDocument/2006/relationships">
+<p:sld xmlns:a="http://schemas.openxmlformats.org/drawingml/2006/main" xmlns:r="http://schemas.openxmlformats.org/officeDocument/2006/relationships" xmlns:p="http://schemas.openxmlformats.org/presentationml/2006/main">
   <p:cSld>
     <p:spTree>
       <p:nvGrpSpPr>
@@ -3434,7 +3446,14 @@
         <p:cNvGrpSpPr/>
         <p:nvPr/>
       </p:nvGrpSpPr>
-      <p:grpSpPr/>
+      <p:grpSpPr>
+        <a:xfrm>
+          <a:off x="0" y="0"/>
+          <a:ext cx="0" cy="0"/>
+          <a:chOff x="0" y="0"/>
+          <a:chExt cx="0" cy="0"/>
+        </a:xfrm>
+      </p:grpSpPr>
       <p:sp>
         <p:nvSpPr>
           <p:cNvPr id="2" name="Rectangle 1"/>
@@ -3475,6 +3494,7 @@
           <a:lstStyle/>
           <a:p>
             <a:pPr algn="ctr"/>
+            <a:endParaRPr/>
           </a:p>
         </p:txBody>
       </p:sp>
@@ -3552,6 +3572,7 @@
           <a:lstStyle/>
           <a:p>
             <a:pPr algn="ctr"/>
+            <a:endParaRPr/>
           </a:p>
         </p:txBody>
       </p:sp>
@@ -3564,7 +3585,7 @@
         <p:spPr>
           <a:xfrm>
             <a:off x="640080" y="1280160"/>
-            <a:ext cx="10515600" cy="5029200"/>
+            <a:ext cx="10515600" cy="2451953"/>
           </a:xfrm>
           <a:prstGeom prst="rect">
             <a:avLst/>
@@ -3589,8 +3610,46 @@
               </a:defRPr>
             </a:pPr>
             <a:r>
-              <a:t>Walmart es el mayor supermercado del mundo: 10.500+ tiendas, 2.3 millones de empleados</a:t>
-            </a:r>
+              <a:rPr dirty="0"/>
+              <a:t>Walmart es </a:t>
+            </a:r>
+            <a:r>
+              <a:rPr dirty="0" err="1"/>
+              <a:t>el</a:t>
+            </a:r>
+            <a:r>
+              <a:rPr dirty="0"/>
+              <a:t> mayor </a:t>
+            </a:r>
+            <a:r>
+              <a:rPr dirty="0" err="1"/>
+              <a:t>supermercado</a:t>
+            </a:r>
+            <a:r>
+              <a:rPr dirty="0"/>
+              <a:t> del </a:t>
+            </a:r>
+            <a:r>
+              <a:rPr dirty="0" err="1"/>
+              <a:t>mundo</a:t>
+            </a:r>
+            <a:r>
+              <a:rPr dirty="0"/>
+              <a:t>: 10.500+ tiendas, 2.3 </a:t>
+            </a:r>
+            <a:r>
+              <a:rPr dirty="0" err="1"/>
+              <a:t>millones</a:t>
+            </a:r>
+            <a:r>
+              <a:rPr dirty="0"/>
+              <a:t> de </a:t>
+            </a:r>
+            <a:r>
+              <a:rPr dirty="0" err="1"/>
+              <a:t>empleados</a:t>
+            </a:r>
+            <a:endParaRPr dirty="0"/>
           </a:p>
           <a:p>
             <a:pPr>
@@ -3605,8 +3664,50 @@
               </a:defRPr>
             </a:pPr>
             <a:r>
-              <a:t>Problema 1: brotes de salmonella y E.coli requieren retirar productos inmediatamente</a:t>
-            </a:r>
+              <a:rPr dirty="0" err="1"/>
+              <a:t>Problema</a:t>
+            </a:r>
+            <a:r>
+              <a:rPr dirty="0"/>
+              <a:t> 1: </a:t>
+            </a:r>
+            <a:r>
+              <a:rPr dirty="0" err="1"/>
+              <a:t>brotes</a:t>
+            </a:r>
+            <a:r>
+              <a:rPr dirty="0"/>
+              <a:t> de salmonella y E.coli </a:t>
+            </a:r>
+            <a:r>
+              <a:rPr dirty="0" err="1"/>
+              <a:t>requieren</a:t>
+            </a:r>
+            <a:r>
+              <a:rPr dirty="0"/>
+              <a:t> </a:t>
+            </a:r>
+            <a:r>
+              <a:rPr dirty="0" err="1"/>
+              <a:t>retirar</a:t>
+            </a:r>
+            <a:r>
+              <a:rPr dirty="0"/>
+              <a:t> </a:t>
+            </a:r>
+            <a:r>
+              <a:rPr dirty="0" err="1"/>
+              <a:t>productos</a:t>
+            </a:r>
+            <a:r>
+              <a:rPr dirty="0"/>
+              <a:t> </a:t>
+            </a:r>
+            <a:r>
+              <a:rPr dirty="0" err="1"/>
+              <a:t>inmediatamente</a:t>
+            </a:r>
+            <a:endParaRPr dirty="0"/>
           </a:p>
           <a:p>
             <a:pPr>
@@ -3621,8 +3722,50 @@
               </a:defRPr>
             </a:pPr>
             <a:r>
-              <a:t>Problema 2: antes de Fabric, rastrear un lote de mango tardaba 7 dias</a:t>
-            </a:r>
+              <a:rPr dirty="0" err="1"/>
+              <a:t>Problema</a:t>
+            </a:r>
+            <a:r>
+              <a:rPr dirty="0"/>
+              <a:t> 2: antes de Fabric, </a:t>
+            </a:r>
+            <a:r>
+              <a:rPr dirty="0" err="1"/>
+              <a:t>rastrear</a:t>
+            </a:r>
+            <a:r>
+              <a:rPr dirty="0"/>
+              <a:t> un </a:t>
+            </a:r>
+            <a:r>
+              <a:rPr dirty="0" err="1"/>
+              <a:t>lote</a:t>
+            </a:r>
+            <a:r>
+              <a:rPr dirty="0"/>
+              <a:t> de </a:t>
+            </a:r>
+            <a:r>
+              <a:rPr lang="es-ES" dirty="0"/>
+              <a:t>producto</a:t>
+            </a:r>
+            <a:r>
+              <a:rPr dirty="0"/>
+              <a:t> </a:t>
+            </a:r>
+            <a:r>
+              <a:rPr dirty="0" err="1"/>
+              <a:t>tardaba</a:t>
+            </a:r>
+            <a:r>
+              <a:rPr dirty="0"/>
+              <a:t> 7 </a:t>
+            </a:r>
+            <a:r>
+              <a:rPr dirty="0" err="1"/>
+              <a:t>dias</a:t>
+            </a:r>
+            <a:endParaRPr dirty="0"/>
           </a:p>
           <a:p>
             <a:pPr>
@@ -3637,8 +3780,74 @@
               </a:defRPr>
             </a:pPr>
             <a:r>
-              <a:t>Problema 3: esos 7 dias = millones de productos potencialmente contaminados en circulacion</a:t>
-            </a:r>
+              <a:rPr dirty="0" err="1"/>
+              <a:t>Problema</a:t>
+            </a:r>
+            <a:r>
+              <a:rPr dirty="0"/>
+              <a:t> 3: </a:t>
+            </a:r>
+            <a:r>
+              <a:rPr dirty="0" err="1"/>
+              <a:t>esos</a:t>
+            </a:r>
+            <a:r>
+              <a:rPr dirty="0"/>
+              <a:t> 7 </a:t>
+            </a:r>
+            <a:r>
+              <a:rPr dirty="0" err="1"/>
+              <a:t>dias</a:t>
+            </a:r>
+            <a:r>
+              <a:rPr dirty="0"/>
+              <a:t> = </a:t>
+            </a:r>
+            <a:r>
+              <a:rPr dirty="0" err="1"/>
+              <a:t>millones</a:t>
+            </a:r>
+            <a:r>
+              <a:rPr dirty="0"/>
+              <a:t> de </a:t>
+            </a:r>
+            <a:r>
+              <a:rPr dirty="0" err="1"/>
+              <a:t>productos</a:t>
+            </a:r>
+            <a:r>
+              <a:rPr dirty="0"/>
+              <a:t> </a:t>
+            </a:r>
+            <a:r>
+              <a:rPr dirty="0" err="1"/>
+              <a:t>potencialmente</a:t>
+            </a:r>
+            <a:r>
+              <a:rPr dirty="0"/>
+              <a:t> </a:t>
+            </a:r>
+            <a:r>
+              <a:rPr dirty="0" err="1"/>
+              <a:t>contaminados</a:t>
+            </a:r>
+            <a:r>
+              <a:rPr dirty="0"/>
+              <a:t> </a:t>
+            </a:r>
+            <a:r>
+              <a:rPr dirty="0" err="1"/>
+              <a:t>en</a:t>
+            </a:r>
+            <a:r>
+              <a:rPr dirty="0"/>
+              <a:t> </a:t>
+            </a:r>
+            <a:r>
+              <a:rPr dirty="0" err="1"/>
+              <a:t>circulacion</a:t>
+            </a:r>
+            <a:endParaRPr dirty="0"/>
           </a:p>
           <a:p>
             <a:pPr>
@@ -3653,8 +3862,66 @@
               </a:defRPr>
             </a:pPr>
             <a:r>
-              <a:t>Problema 4: cada proveedor tenia su propio sistema, imposible de consolidar</a:t>
-            </a:r>
+              <a:rPr dirty="0" err="1"/>
+              <a:t>Problema</a:t>
+            </a:r>
+            <a:r>
+              <a:rPr dirty="0"/>
+              <a:t> 4: </a:t>
+            </a:r>
+            <a:r>
+              <a:rPr dirty="0" err="1"/>
+              <a:t>cada</a:t>
+            </a:r>
+            <a:r>
+              <a:rPr dirty="0"/>
+              <a:t> </a:t>
+            </a:r>
+            <a:r>
+              <a:rPr dirty="0" err="1"/>
+              <a:t>proveedor</a:t>
+            </a:r>
+            <a:r>
+              <a:rPr dirty="0"/>
+              <a:t> tenia </a:t>
+            </a:r>
+            <a:r>
+              <a:rPr dirty="0" err="1"/>
+              <a:t>su</a:t>
+            </a:r>
+            <a:r>
+              <a:rPr dirty="0"/>
+              <a:t> </a:t>
+            </a:r>
+            <a:r>
+              <a:rPr dirty="0" err="1"/>
+              <a:t>propio</a:t>
+            </a:r>
+            <a:r>
+              <a:rPr dirty="0"/>
+              <a:t> </a:t>
+            </a:r>
+            <a:r>
+              <a:rPr dirty="0" err="1"/>
+              <a:t>sistema</a:t>
+            </a:r>
+            <a:r>
+              <a:rPr dirty="0"/>
+              <a:t>, </a:t>
+            </a:r>
+            <a:r>
+              <a:rPr dirty="0" err="1"/>
+              <a:t>imposible</a:t>
+            </a:r>
+            <a:r>
+              <a:rPr dirty="0"/>
+              <a:t> de </a:t>
+            </a:r>
+            <a:r>
+              <a:rPr dirty="0" err="1"/>
+              <a:t>consolidar</a:t>
+            </a:r>
+            <a:endParaRPr dirty="0"/>
           </a:p>
           <a:p>
             <a:pPr>
@@ -3669,8 +3936,78 @@
               </a:defRPr>
             </a:pPr>
             <a:r>
-              <a:t>Coste estimado: cada dia de retraso en un recall = millones de dolares en perdidas</a:t>
-            </a:r>
+              <a:rPr dirty="0"/>
+              <a:t>Coste </a:t>
+            </a:r>
+            <a:r>
+              <a:rPr dirty="0" err="1"/>
+              <a:t>estimado</a:t>
+            </a:r>
+            <a:r>
+              <a:rPr dirty="0"/>
+              <a:t>: </a:t>
+            </a:r>
+            <a:r>
+              <a:rPr dirty="0" err="1"/>
+              <a:t>cada</a:t>
+            </a:r>
+            <a:r>
+              <a:rPr dirty="0"/>
+              <a:t> </a:t>
+            </a:r>
+            <a:r>
+              <a:rPr dirty="0" err="1"/>
+              <a:t>dia</a:t>
+            </a:r>
+            <a:r>
+              <a:rPr dirty="0"/>
+              <a:t> de </a:t>
+            </a:r>
+            <a:r>
+              <a:rPr dirty="0" err="1"/>
+              <a:t>retraso</a:t>
+            </a:r>
+            <a:r>
+              <a:rPr dirty="0"/>
+              <a:t> </a:t>
+            </a:r>
+            <a:r>
+              <a:rPr dirty="0" err="1"/>
+              <a:t>en</a:t>
+            </a:r>
+            <a:r>
+              <a:rPr dirty="0"/>
+              <a:t> un recall = </a:t>
+            </a:r>
+            <a:r>
+              <a:rPr dirty="0" err="1"/>
+              <a:t>millones</a:t>
+            </a:r>
+            <a:r>
+              <a:rPr dirty="0"/>
+              <a:t> de </a:t>
+            </a:r>
+            <a:r>
+              <a:rPr dirty="0" err="1"/>
+              <a:t>dolares</a:t>
+            </a:r>
+            <a:r>
+              <a:rPr dirty="0"/>
+              <a:t> </a:t>
+            </a:r>
+            <a:r>
+              <a:rPr dirty="0" err="1"/>
+              <a:t>en</a:t>
+            </a:r>
+            <a:r>
+              <a:rPr dirty="0"/>
+              <a:t> </a:t>
+            </a:r>
+            <a:r>
+              <a:rPr dirty="0" err="1"/>
+              <a:t>perdidas</a:t>
+            </a:r>
+            <a:endParaRPr dirty="0"/>
           </a:p>
         </p:txBody>
       </p:sp>
@@ -3683,7 +4020,7 @@
 </file>
 
 <file path=ppt/slides/slide4.xml><?xml version="1.0" encoding="utf-8"?>
-<p:sld xmlns:a="http://schemas.openxmlformats.org/drawingml/2006/main" xmlns:p="http://schemas.openxmlformats.org/presentationml/2006/main" xmlns:r="http://schemas.openxmlformats.org/officeDocument/2006/relationships">
+<p:sld xmlns:a="http://schemas.openxmlformats.org/drawingml/2006/main" xmlns:r="http://schemas.openxmlformats.org/officeDocument/2006/relationships" xmlns:p="http://schemas.openxmlformats.org/presentationml/2006/main">
   <p:cSld>
     <p:spTree>
       <p:nvGrpSpPr>
@@ -3691,7 +4028,14 @@
         <p:cNvGrpSpPr/>
         <p:nvPr/>
       </p:nvGrpSpPr>
-      <p:grpSpPr/>
+      <p:grpSpPr>
+        <a:xfrm>
+          <a:off x="0" y="0"/>
+          <a:ext cx="0" cy="0"/>
+          <a:chOff x="0" y="0"/>
+          <a:chExt cx="0" cy="0"/>
+        </a:xfrm>
+      </p:grpSpPr>
       <p:sp>
         <p:nvSpPr>
           <p:cNvPr id="2" name="Rectangle 1"/>
@@ -3732,6 +4076,7 @@
           <a:lstStyle/>
           <a:p>
             <a:pPr algn="ctr"/>
+            <a:endParaRPr/>
           </a:p>
         </p:txBody>
       </p:sp>
@@ -3809,6 +4154,7 @@
           <a:lstStyle/>
           <a:p>
             <a:pPr algn="ctr"/>
+            <a:endParaRPr/>
           </a:p>
         </p:txBody>
       </p:sp>
@@ -4020,7 +4366,7 @@
 </file>
 
 <file path=ppt/slides/slide5.xml><?xml version="1.0" encoding="utf-8"?>
-<p:sld xmlns:a="http://schemas.openxmlformats.org/drawingml/2006/main" xmlns:p="http://schemas.openxmlformats.org/presentationml/2006/main" xmlns:r="http://schemas.openxmlformats.org/officeDocument/2006/relationships">
+<p:sld xmlns:a="http://schemas.openxmlformats.org/drawingml/2006/main" xmlns:r="http://schemas.openxmlformats.org/officeDocument/2006/relationships" xmlns:p="http://schemas.openxmlformats.org/presentationml/2006/main">
   <p:cSld>
     <p:spTree>
       <p:nvGrpSpPr>
@@ -4028,7 +4374,14 @@
         <p:cNvGrpSpPr/>
         <p:nvPr/>
       </p:nvGrpSpPr>
-      <p:grpSpPr/>
+      <p:grpSpPr>
+        <a:xfrm>
+          <a:off x="0" y="0"/>
+          <a:ext cx="0" cy="0"/>
+          <a:chOff x="0" y="0"/>
+          <a:chExt cx="0" cy="0"/>
+        </a:xfrm>
+      </p:grpSpPr>
       <p:sp>
         <p:nvSpPr>
           <p:cNvPr id="2" name="Rectangle 1"/>
@@ -4069,6 +4422,7 @@
           <a:lstStyle/>
           <a:p>
             <a:pPr algn="ctr"/>
+            <a:endParaRPr/>
           </a:p>
         </p:txBody>
       </p:sp>
@@ -4146,6 +4500,7 @@
           <a:lstStyle/>
           <a:p>
             <a:pPr algn="ctr"/>
+            <a:endParaRPr/>
           </a:p>
         </p:txBody>
       </p:sp>
@@ -4277,7 +4632,7 @@
 </file>
 
 <file path=ppt/slides/slide6.xml><?xml version="1.0" encoding="utf-8"?>
-<p:sld xmlns:a="http://schemas.openxmlformats.org/drawingml/2006/main" xmlns:p="http://schemas.openxmlformats.org/presentationml/2006/main" xmlns:r="http://schemas.openxmlformats.org/officeDocument/2006/relationships">
+<p:sld xmlns:a="http://schemas.openxmlformats.org/drawingml/2006/main" xmlns:r="http://schemas.openxmlformats.org/officeDocument/2006/relationships" xmlns:p="http://schemas.openxmlformats.org/presentationml/2006/main">
   <p:cSld>
     <p:spTree>
       <p:nvGrpSpPr>
@@ -4285,7 +4640,14 @@
         <p:cNvGrpSpPr/>
         <p:nvPr/>
       </p:nvGrpSpPr>
-      <p:grpSpPr/>
+      <p:grpSpPr>
+        <a:xfrm>
+          <a:off x="0" y="0"/>
+          <a:ext cx="0" cy="0"/>
+          <a:chOff x="0" y="0"/>
+          <a:chExt cx="0" cy="0"/>
+        </a:xfrm>
+      </p:grpSpPr>
       <p:sp>
         <p:nvSpPr>
           <p:cNvPr id="2" name="Rectangle 1"/>
@@ -4326,6 +4688,7 @@
           <a:lstStyle/>
           <a:p>
             <a:pPr algn="ctr"/>
+            <a:endParaRPr/>
           </a:p>
         </p:txBody>
       </p:sp>
@@ -4403,197 +4766,40 @@
           <a:lstStyle/>
           <a:p>
             <a:pPr algn="ctr"/>
-          </a:p>
-        </p:txBody>
-      </p:sp>
-      <p:sp>
-        <p:nvSpPr>
-          <p:cNvPr id="5" name="Rectangle 4"/>
-          <p:cNvSpPr/>
+            <a:endParaRPr/>
+          </a:p>
+        </p:txBody>
+      </p:sp>
+      <p:pic>
+        <p:nvPicPr>
+          <p:cNvPr id="11" name="Imagen 10">
+            <a:extLst>
+              <a:ext uri="{FF2B5EF4-FFF2-40B4-BE49-F238E27FC236}">
+                <a16:creationId xmlns:a16="http://schemas.microsoft.com/office/drawing/2014/main" id="{9D41DE5C-CADF-11F3-FC8C-E4FD97C27437}"/>
+              </a:ext>
+            </a:extLst>
+          </p:cNvPr>
+          <p:cNvPicPr>
+            <a:picLocks noChangeAspect="1"/>
+          </p:cNvPicPr>
           <p:nvPr/>
-        </p:nvSpPr>
+        </p:nvPicPr>
+        <p:blipFill>
+          <a:blip r:embed="rId2"/>
+          <a:stretch>
+            <a:fillRect/>
+          </a:stretch>
+        </p:blipFill>
         <p:spPr>
           <a:xfrm>
-            <a:off x="1371600" y="1371600"/>
-            <a:ext cx="9418320" cy="4114800"/>
+            <a:off x="1471961" y="1492253"/>
+            <a:ext cx="9244904" cy="5010918"/>
           </a:xfrm>
           <a:prstGeom prst="rect">
             <a:avLst/>
           </a:prstGeom>
-          <a:solidFill>
-            <a:srgbClr val="F2F2F2"/>
-          </a:solidFill>
-          <a:ln>
-            <a:noFill/>
-          </a:ln>
         </p:spPr>
-        <p:style>
-          <a:lnRef idx="1">
-            <a:schemeClr val="accent1"/>
-          </a:lnRef>
-          <a:fillRef idx="3">
-            <a:schemeClr val="accent1"/>
-          </a:fillRef>
-          <a:effectRef idx="2">
-            <a:schemeClr val="accent1"/>
-          </a:effectRef>
-          <a:fontRef idx="minor">
-            <a:schemeClr val="lt1"/>
-          </a:fontRef>
-        </p:style>
-        <p:txBody>
-          <a:bodyPr rtlCol="0" anchor="ctr"/>
-          <a:lstStyle/>
-          <a:p>
-            <a:pPr algn="ctr"/>
-          </a:p>
-        </p:txBody>
-      </p:sp>
-      <p:sp>
-        <p:nvSpPr>
-          <p:cNvPr id="6" name="TextBox 5"/>
-          <p:cNvSpPr txBox="1"/>
-          <p:nvPr/>
-        </p:nvSpPr>
-        <p:spPr>
-          <a:xfrm>
-            <a:off x="1828800" y="2286000"/>
-            <a:ext cx="8503920" cy="1371600"/>
-          </a:xfrm>
-          <a:prstGeom prst="rect">
-            <a:avLst/>
-          </a:prstGeom>
-          <a:noFill/>
-        </p:spPr>
-        <p:txBody>
-          <a:bodyPr wrap="square"/>
-          <a:lstStyle/>
-          <a:p>
-            <a:pPr algn="ctr">
-              <a:defRPr sz="2400" b="0">
-                <a:solidFill>
-                  <a:srgbClr val="999999"/>
-                </a:solidFill>
-                <a:latin typeface="Calibri"/>
-              </a:defRPr>
-            </a:pPr>
-            <a:r>
-              <a:t>[Diagrama: granja -&gt; procesador -&gt; distribuidor -&gt; supermercado, todos conectados a un canal Fabric compartido]</a:t>
-            </a:r>
-          </a:p>
-        </p:txBody>
-      </p:sp>
-      <p:sp>
-        <p:nvSpPr>
-          <p:cNvPr id="7" name="Rectangle 6"/>
-          <p:cNvSpPr/>
-          <p:nvPr/>
-        </p:nvSpPr>
-        <p:spPr>
-          <a:xfrm>
-            <a:off x="1371600" y="3840480"/>
-            <a:ext cx="9418320" cy="320040"/>
-          </a:xfrm>
-          <a:prstGeom prst="rect">
-            <a:avLst/>
-          </a:prstGeom>
-          <a:solidFill>
-            <a:srgbClr val="7C3AED"/>
-          </a:solidFill>
-          <a:ln>
-            <a:noFill/>
-          </a:ln>
-        </p:spPr>
-        <p:style>
-          <a:lnRef idx="1">
-            <a:schemeClr val="accent1"/>
-          </a:lnRef>
-          <a:fillRef idx="3">
-            <a:schemeClr val="accent1"/>
-          </a:fillRef>
-          <a:effectRef idx="2">
-            <a:schemeClr val="accent1"/>
-          </a:effectRef>
-          <a:fontRef idx="minor">
-            <a:schemeClr val="lt1"/>
-          </a:fontRef>
-        </p:style>
-        <p:txBody>
-          <a:bodyPr rtlCol="0" anchor="ctr"/>
-          <a:lstStyle/>
-          <a:p>
-            <a:pPr algn="ctr"/>
-          </a:p>
-        </p:txBody>
-      </p:sp>
-      <p:sp>
-        <p:nvSpPr>
-          <p:cNvPr id="8" name="TextBox 7"/>
-          <p:cNvSpPr txBox="1"/>
-          <p:nvPr/>
-        </p:nvSpPr>
-        <p:spPr>
-          <a:xfrm>
-            <a:off x="1371600" y="3840480"/>
-            <a:ext cx="9418320" cy="320040"/>
-          </a:xfrm>
-          <a:prstGeom prst="rect">
-            <a:avLst/>
-          </a:prstGeom>
-          <a:noFill/>
-        </p:spPr>
-        <p:txBody>
-          <a:bodyPr wrap="square"/>
-          <a:lstStyle/>
-          <a:p>
-            <a:pPr algn="ctr">
-              <a:defRPr sz="1300" b="1">
-                <a:solidFill>
-                  <a:srgbClr val="FFFFFF"/>
-                </a:solidFill>
-                <a:latin typeface="Calibri"/>
-              </a:defRPr>
-            </a:pPr>
-            <a:r>
-              <a:t>Prompt para IA generativa:</a:t>
-            </a:r>
-          </a:p>
-        </p:txBody>
-      </p:sp>
-      <p:sp>
-        <p:nvSpPr>
-          <p:cNvPr id="9" name="TextBox 8"/>
-          <p:cNvSpPr txBox="1"/>
-          <p:nvPr/>
-        </p:nvSpPr>
-        <p:spPr>
-          <a:xfrm>
-            <a:off x="1645920" y="4297680"/>
-            <a:ext cx="8869680" cy="914400"/>
-          </a:xfrm>
-          <a:prstGeom prst="rect">
-            <a:avLst/>
-          </a:prstGeom>
-          <a:noFill/>
-        </p:spPr>
-        <p:txBody>
-          <a:bodyPr wrap="square"/>
-          <a:lstStyle/>
-          <a:p>
-            <a:pPr algn="l">
-              <a:defRPr sz="1400" b="0">
-                <a:solidFill>
-                  <a:srgbClr val="7C3AED"/>
-                </a:solidFill>
-                <a:latin typeface="Consolas"/>
-              </a:defRPr>
-            </a:pPr>
-            <a:r>
-              <a:t>Supply chain diagram for IBM Food Trust on Hyperledger Fabric: four organizations (Farm, Processor, Distributor, Walmart Store) each with their own peer node, connected through a shared channel. Orderer service in the middle. Food icons (mango, leafy greens) flowing through the chain. Clean flat design, teal color scheme.</a:t>
-            </a:r>
-          </a:p>
-        </p:txBody>
-      </p:sp>
+      </p:pic>
     </p:spTree>
   </p:cSld>
   <p:clrMapOvr>
@@ -4603,7 +4809,7 @@
 </file>
 
 <file path=ppt/slides/slide7.xml><?xml version="1.0" encoding="utf-8"?>
-<p:sld xmlns:a="http://schemas.openxmlformats.org/drawingml/2006/main" xmlns:p="http://schemas.openxmlformats.org/presentationml/2006/main" xmlns:r="http://schemas.openxmlformats.org/officeDocument/2006/relationships">
+<p:sld xmlns:a="http://schemas.openxmlformats.org/drawingml/2006/main" xmlns:r="http://schemas.openxmlformats.org/officeDocument/2006/relationships" xmlns:p="http://schemas.openxmlformats.org/presentationml/2006/main">
   <p:cSld>
     <p:spTree>
       <p:nvGrpSpPr>
@@ -4611,7 +4817,14 @@
         <p:cNvGrpSpPr/>
         <p:nvPr/>
       </p:nvGrpSpPr>
-      <p:grpSpPr/>
+      <p:grpSpPr>
+        <a:xfrm>
+          <a:off x="0" y="0"/>
+          <a:ext cx="0" cy="0"/>
+          <a:chOff x="0" y="0"/>
+          <a:chExt cx="0" cy="0"/>
+        </a:xfrm>
+      </p:grpSpPr>
       <p:sp>
         <p:nvSpPr>
           <p:cNvPr id="2" name="Rectangle 1"/>
@@ -4652,6 +4865,7 @@
           <a:lstStyle/>
           <a:p>
             <a:pPr algn="ctr"/>
+            <a:endParaRPr/>
           </a:p>
         </p:txBody>
       </p:sp>
@@ -4695,6 +4909,7 @@
           <a:lstStyle/>
           <a:p>
             <a:pPr algn="ctr"/>
+            <a:endParaRPr/>
           </a:p>
         </p:txBody>
       </p:sp>
@@ -4806,6 +5021,7 @@
           <a:lstStyle/>
           <a:p>
             <a:pPr algn="ctr"/>
+            <a:endParaRPr/>
           </a:p>
         </p:txBody>
       </p:sp>
@@ -4818,7 +5034,7 @@
         <p:spPr>
           <a:xfrm>
             <a:off x="640080" y="1371600"/>
-            <a:ext cx="10515600" cy="5029200"/>
+            <a:ext cx="8147081" cy="5196294"/>
           </a:xfrm>
           <a:prstGeom prst="rect">
             <a:avLst/>
@@ -4843,7 +5059,40 @@
               </a:defRPr>
             </a:pPr>
             <a:r>
-              <a:t>Caso practico adaptado al aula: trazabilidad de aguacates de Malaga</a:t>
+              <a:rPr dirty="0"/>
+              <a:t>Caso </a:t>
+            </a:r>
+            <a:r>
+              <a:rPr dirty="0" err="1"/>
+              <a:t>practico</a:t>
+            </a:r>
+            <a:r>
+              <a:rPr dirty="0"/>
+              <a:t> </a:t>
+            </a:r>
+            <a:r>
+              <a:rPr dirty="0" err="1"/>
+              <a:t>adaptado</a:t>
+            </a:r>
+            <a:r>
+              <a:rPr dirty="0"/>
+              <a:t> al aula: </a:t>
+            </a:r>
+            <a:r>
+              <a:rPr dirty="0" err="1"/>
+              <a:t>trazabilidad</a:t>
+            </a:r>
+            <a:r>
+              <a:rPr dirty="0"/>
+              <a:t> de </a:t>
+            </a:r>
+            <a:r>
+              <a:rPr dirty="0" err="1"/>
+              <a:t>aguacates</a:t>
+            </a:r>
+            <a:r>
+              <a:rPr dirty="0"/>
+              <a:t> de Malaga</a:t>
             </a:r>
           </a:p>
           <a:p>
@@ -4858,6 +5107,7 @@
                 <a:latin typeface="Calibri"/>
               </a:defRPr>
             </a:pPr>
+            <a:endParaRPr dirty="0"/>
           </a:p>
           <a:p>
             <a:pPr>
@@ -4872,7 +5122,20 @@
               </a:defRPr>
             </a:pPr>
             <a:r>
-              <a:t>Actores del consorcio:</a:t>
+              <a:rPr dirty="0" err="1"/>
+              <a:t>Actores</a:t>
+            </a:r>
+            <a:r>
+              <a:rPr dirty="0"/>
+              <a:t> del </a:t>
+            </a:r>
+            <a:r>
+              <a:rPr dirty="0" err="1"/>
+              <a:t>consorcio</a:t>
+            </a:r>
+            <a:r>
+              <a:rPr dirty="0"/>
+              <a:t>:</a:t>
             </a:r>
           </a:p>
           <a:p>
@@ -4888,7 +5151,16 @@
               </a:defRPr>
             </a:pPr>
             <a:r>
-              <a:t>  - Productor (granja)</a:t>
+              <a:rPr dirty="0"/>
+              <a:t>  - Productor (</a:t>
+            </a:r>
+            <a:r>
+              <a:rPr dirty="0" err="1"/>
+              <a:t>granja</a:t>
+            </a:r>
+            <a:r>
+              <a:rPr dirty="0"/>
+              <a:t>)</a:t>
             </a:r>
           </a:p>
           <a:p>
@@ -4904,7 +5176,32 @@
               </a:defRPr>
             </a:pPr>
             <a:r>
-              <a:t>  - Distribuidor (transporte refrigerado)</a:t>
+              <a:rPr dirty="0"/>
+              <a:t>  - </a:t>
+            </a:r>
+            <a:r>
+              <a:rPr dirty="0" err="1"/>
+              <a:t>Distribuidor</a:t>
+            </a:r>
+            <a:r>
+              <a:rPr dirty="0"/>
+              <a:t> (</a:t>
+            </a:r>
+            <a:r>
+              <a:rPr dirty="0" err="1"/>
+              <a:t>transporte</a:t>
+            </a:r>
+            <a:r>
+              <a:rPr dirty="0"/>
+              <a:t> </a:t>
+            </a:r>
+            <a:r>
+              <a:rPr dirty="0" err="1"/>
+              <a:t>refrigerado</a:t>
+            </a:r>
+            <a:r>
+              <a:rPr dirty="0"/>
+              <a:t>)</a:t>
             </a:r>
           </a:p>
           <a:p>
@@ -4920,7 +5217,16 @@
               </a:defRPr>
             </a:pPr>
             <a:r>
-              <a:t>  - Supermercado (venta final)</a:t>
+              <a:rPr dirty="0"/>
+              <a:t>  - Supermercado (</a:t>
+            </a:r>
+            <a:r>
+              <a:rPr dirty="0" err="1"/>
+              <a:t>venta</a:t>
+            </a:r>
+            <a:r>
+              <a:rPr dirty="0"/>
+              <a:t> final)</a:t>
             </a:r>
           </a:p>
           <a:p>
@@ -4936,7 +5242,24 @@
               </a:defRPr>
             </a:pPr>
             <a:r>
-              <a:t>  - Regulador (AESAN - seguridad alimentaria)</a:t>
+              <a:rPr dirty="0"/>
+              <a:t>  - </a:t>
+            </a:r>
+            <a:r>
+              <a:rPr dirty="0" err="1"/>
+              <a:t>Regulador</a:t>
+            </a:r>
+            <a:r>
+              <a:rPr dirty="0"/>
+              <a:t> (AESAN - </a:t>
+            </a:r>
+            <a:r>
+              <a:rPr dirty="0" err="1"/>
+              <a:t>seguridad</a:t>
+            </a:r>
+            <a:r>
+              <a:rPr dirty="0"/>
+              <a:t> alimentaria)</a:t>
             </a:r>
           </a:p>
           <a:p>
@@ -4951,6 +5274,7 @@
                 <a:latin typeface="Calibri"/>
               </a:defRPr>
             </a:pPr>
+            <a:endParaRPr lang="es-ES" dirty="0"/>
           </a:p>
           <a:p>
             <a:pPr>
@@ -4964,9 +5288,7 @@
                 <a:latin typeface="Calibri"/>
               </a:defRPr>
             </a:pPr>
-            <a:r>
-              <a:t>Tareas:</a:t>
-            </a:r>
+            <a:endParaRPr lang="es-ES" dirty="0"/>
           </a:p>
           <a:p>
             <a:pPr>
@@ -4980,9 +5302,7 @@
                 <a:latin typeface="Calibri"/>
               </a:defRPr>
             </a:pPr>
-            <a:r>
-              <a:t>  FASE 1 (sobre el papel, 30 min):</a:t>
-            </a:r>
+            <a:endParaRPr lang="es-ES" dirty="0"/>
           </a:p>
           <a:p>
             <a:pPr>
@@ -4996,9 +5316,7 @@
                 <a:latin typeface="Calibri"/>
               </a:defRPr>
             </a:pPr>
-            <a:r>
-              <a:t>    Disenar la topologia de red: cuantas orgs, canales, Private Data</a:t>
-            </a:r>
+            <a:endParaRPr dirty="0"/>
           </a:p>
           <a:p>
             <a:pPr>
@@ -5013,9 +5331,47 @@
               </a:defRPr>
             </a:pPr>
             <a:r>
-              <a:t>    Decidir politicas de endorsement y control de acceso</a:t>
-            </a:r>
-          </a:p>
+              <a:rPr dirty="0"/>
+              <a:t>Guia </a:t>
+            </a:r>
+            <a:r>
+              <a:rPr dirty="0" err="1"/>
+              <a:t>tecnica</a:t>
+            </a:r>
+            <a:r>
+              <a:rPr dirty="0"/>
+              <a:t> completa: docs/modulo-3/ejercicios/ejercicio-walmart.md</a:t>
+            </a:r>
+          </a:p>
+        </p:txBody>
+      </p:sp>
+      <p:sp>
+        <p:nvSpPr>
+          <p:cNvPr id="9" name="CuadroTexto 8">
+            <a:extLst>
+              <a:ext uri="{FF2B5EF4-FFF2-40B4-BE49-F238E27FC236}">
+                <a16:creationId xmlns:a16="http://schemas.microsoft.com/office/drawing/2014/main" id="{D25BA6A5-778B-1651-2E89-2C6A128C34DB}"/>
+              </a:ext>
+            </a:extLst>
+          </p:cNvPr>
+          <p:cNvSpPr txBox="1"/>
+          <p:nvPr/>
+        </p:nvSpPr>
+        <p:spPr>
+          <a:xfrm>
+            <a:off x="6094412" y="1824880"/>
+            <a:ext cx="6138746" cy="3760004"/>
+          </a:xfrm>
+          <a:prstGeom prst="rect">
+            <a:avLst/>
+          </a:prstGeom>
+          <a:noFill/>
+        </p:spPr>
+        <p:txBody>
+          <a:bodyPr wrap="square">
+            <a:spAutoFit/>
+          </a:bodyPr>
+          <a:lstStyle/>
           <a:p>
             <a:pPr>
               <a:spcAft>
@@ -5029,7 +5385,8 @@
               </a:defRPr>
             </a:pPr>
             <a:r>
-              <a:t>  FASE 2 (en el ordenador, 90 min):</a:t>
+              <a:rPr lang="es-ES" dirty="0"/>
+              <a:t>Tareas:</a:t>
             </a:r>
           </a:p>
           <a:p>
@@ -5045,7 +5402,8 @@
               </a:defRPr>
             </a:pPr>
             <a:r>
-              <a:t>    Montar la red con 4 organizaciones + orderer</a:t>
+              <a:rPr lang="es-ES" dirty="0"/>
+              <a:t>  FASE 1:</a:t>
             </a:r>
           </a:p>
           <a:p>
@@ -5061,7 +5419,40 @@
               </a:defRPr>
             </a:pPr>
             <a:r>
-              <a:t>    Desplegar el chaincode con Private Data Collections</a:t>
+              <a:rPr lang="es-ES" dirty="0"/>
+              <a:t>    </a:t>
+            </a:r>
+            <a:r>
+              <a:rPr lang="es-ES" dirty="0" err="1"/>
+              <a:t>Disenar</a:t>
+            </a:r>
+            <a:r>
+              <a:rPr lang="es-ES" dirty="0"/>
+              <a:t> la </a:t>
+            </a:r>
+            <a:r>
+              <a:rPr lang="es-ES" dirty="0" err="1"/>
+              <a:t>topologia</a:t>
+            </a:r>
+            <a:r>
+              <a:rPr lang="es-ES" dirty="0"/>
+              <a:t> de red: cuantas </a:t>
+            </a:r>
+            <a:r>
+              <a:rPr lang="es-ES" dirty="0" err="1"/>
+              <a:t>orgs</a:t>
+            </a:r>
+            <a:r>
+              <a:rPr lang="es-ES" dirty="0"/>
+              <a:t>, canales, </a:t>
+            </a:r>
+            <a:r>
+              <a:rPr lang="es-ES" dirty="0" err="1"/>
+              <a:t>Private</a:t>
+            </a:r>
+            <a:r>
+              <a:rPr lang="es-ES" dirty="0"/>
+              <a:t> Data</a:t>
             </a:r>
           </a:p>
           <a:p>
@@ -5077,7 +5468,24 @@
               </a:defRPr>
             </a:pPr>
             <a:r>
-              <a:t>    Probar el flujo completo de trazabilidad y un recall</a:t>
+              <a:rPr lang="es-ES" dirty="0"/>
+              <a:t>    Decidir </a:t>
+            </a:r>
+            <a:r>
+              <a:rPr lang="es-ES" dirty="0" err="1"/>
+              <a:t>politicas</a:t>
+            </a:r>
+            <a:r>
+              <a:rPr lang="es-ES" dirty="0"/>
+              <a:t> de </a:t>
+            </a:r>
+            <a:r>
+              <a:rPr lang="es-ES" dirty="0" err="1"/>
+              <a:t>endorsement</a:t>
+            </a:r>
+            <a:r>
+              <a:rPr lang="es-ES" dirty="0"/>
+              <a:t> y control de acceso</a:t>
             </a:r>
           </a:p>
           <a:p>
@@ -5092,6 +5500,10 @@
                 <a:latin typeface="Calibri"/>
               </a:defRPr>
             </a:pPr>
+            <a:r>
+              <a:rPr lang="es-ES" dirty="0"/>
+              <a:t>  FASE 2:</a:t>
+            </a:r>
           </a:p>
           <a:p>
             <a:pPr>
@@ -5106,8 +5518,74 @@
               </a:defRPr>
             </a:pPr>
             <a:r>
-              <a:t>Guia tecnica completa: docs/modulo-3/ejercicios/ejercicio-walmart.md</a:t>
-            </a:r>
+              <a:rPr lang="es-ES" dirty="0"/>
+              <a:t>    Montar la red con 4 organizaciones + </a:t>
+            </a:r>
+            <a:r>
+              <a:rPr lang="es-ES" dirty="0" err="1"/>
+              <a:t>orderer</a:t>
+            </a:r>
+            <a:endParaRPr lang="es-ES" dirty="0"/>
+          </a:p>
+          <a:p>
+            <a:pPr>
+              <a:spcAft>
+                <a:spcPts val="1000"/>
+              </a:spcAft>
+              <a:defRPr sz="2000">
+                <a:solidFill>
+                  <a:srgbClr val="333333"/>
+                </a:solidFill>
+                <a:latin typeface="Calibri"/>
+              </a:defRPr>
+            </a:pPr>
+            <a:r>
+              <a:rPr lang="es-ES" dirty="0"/>
+              <a:t>    Desplegar el </a:t>
+            </a:r>
+            <a:r>
+              <a:rPr lang="es-ES" dirty="0" err="1"/>
+              <a:t>chaincode</a:t>
+            </a:r>
+            <a:r>
+              <a:rPr lang="es-ES" dirty="0"/>
+              <a:t> con </a:t>
+            </a:r>
+            <a:r>
+              <a:rPr lang="es-ES" dirty="0" err="1"/>
+              <a:t>Private</a:t>
+            </a:r>
+            <a:r>
+              <a:rPr lang="es-ES" dirty="0"/>
+              <a:t> Data </a:t>
+            </a:r>
+            <a:r>
+              <a:rPr lang="es-ES" dirty="0" err="1"/>
+              <a:t>Collections</a:t>
+            </a:r>
+            <a:endParaRPr lang="es-ES" dirty="0"/>
+          </a:p>
+          <a:p>
+            <a:pPr>
+              <a:spcAft>
+                <a:spcPts val="1000"/>
+              </a:spcAft>
+              <a:defRPr sz="2000">
+                <a:solidFill>
+                  <a:srgbClr val="333333"/>
+                </a:solidFill>
+                <a:latin typeface="Calibri"/>
+              </a:defRPr>
+            </a:pPr>
+            <a:r>
+              <a:rPr lang="es-ES" dirty="0"/>
+              <a:t>    Probar el flujo completo de trazabilidad y un </a:t>
+            </a:r>
+            <a:r>
+              <a:rPr lang="es-ES" dirty="0" err="1"/>
+              <a:t>recall</a:t>
+            </a:r>
+            <a:endParaRPr lang="es-ES" dirty="0"/>
           </a:p>
         </p:txBody>
       </p:sp>
@@ -5120,7 +5598,7 @@
 </file>
 
 <file path=ppt/slides/slide8.xml><?xml version="1.0" encoding="utf-8"?>
-<p:sld xmlns:a="http://schemas.openxmlformats.org/drawingml/2006/main" xmlns:p="http://schemas.openxmlformats.org/presentationml/2006/main" xmlns:r="http://schemas.openxmlformats.org/officeDocument/2006/relationships">
+<p:sld xmlns:a="http://schemas.openxmlformats.org/drawingml/2006/main" xmlns:r="http://schemas.openxmlformats.org/officeDocument/2006/relationships" xmlns:p="http://schemas.openxmlformats.org/presentationml/2006/main">
   <p:cSld>
     <p:spTree>
       <p:nvGrpSpPr>
@@ -5128,7 +5606,14 @@
         <p:cNvGrpSpPr/>
         <p:nvPr/>
       </p:nvGrpSpPr>
-      <p:grpSpPr/>
+      <p:grpSpPr>
+        <a:xfrm>
+          <a:off x="0" y="0"/>
+          <a:ext cx="0" cy="0"/>
+          <a:chOff x="0" y="0"/>
+          <a:chExt cx="0" cy="0"/>
+        </a:xfrm>
+      </p:grpSpPr>
       <p:sp>
         <p:nvSpPr>
           <p:cNvPr id="2" name="Rectangle 1"/>
@@ -5169,6 +5654,7 @@
           <a:lstStyle/>
           <a:p>
             <a:pPr algn="ctr"/>
+            <a:endParaRPr/>
           </a:p>
         </p:txBody>
       </p:sp>
@@ -5246,6 +5732,7 @@
           <a:lstStyle/>
           <a:p>
             <a:pPr algn="ctr"/>
+            <a:endParaRPr/>
           </a:p>
         </p:txBody>
       </p:sp>
@@ -5298,6 +5785,7 @@
                 <a:latin typeface="Calibri"/>
               </a:defRPr>
             </a:pPr>
+            <a:endParaRPr/>
           </a:p>
           <a:p>
             <a:pPr>
@@ -5454,7 +5942,7 @@
 </file>
 
 <file path=ppt/slides/slide9.xml><?xml version="1.0" encoding="utf-8"?>
-<p:sld xmlns:a="http://schemas.openxmlformats.org/drawingml/2006/main" xmlns:p="http://schemas.openxmlformats.org/presentationml/2006/main" xmlns:r="http://schemas.openxmlformats.org/officeDocument/2006/relationships">
+<p:sld xmlns:a="http://schemas.openxmlformats.org/drawingml/2006/main" xmlns:r="http://schemas.openxmlformats.org/officeDocument/2006/relationships" xmlns:p="http://schemas.openxmlformats.org/presentationml/2006/main">
   <p:cSld>
     <p:spTree>
       <p:nvGrpSpPr>
@@ -5462,7 +5950,14 @@
         <p:cNvGrpSpPr/>
         <p:nvPr/>
       </p:nvGrpSpPr>
-      <p:grpSpPr/>
+      <p:grpSpPr>
+        <a:xfrm>
+          <a:off x="0" y="0"/>
+          <a:ext cx="0" cy="0"/>
+          <a:chOff x="0" y="0"/>
+          <a:chExt cx="0" cy="0"/>
+        </a:xfrm>
+      </p:grpSpPr>
       <p:sp>
         <p:nvSpPr>
           <p:cNvPr id="2" name="Rectangle 1"/>
@@ -5503,6 +5998,7 @@
           <a:lstStyle/>
           <a:p>
             <a:pPr algn="ctr"/>
+            <a:endParaRPr/>
           </a:p>
         </p:txBody>
       </p:sp>
@@ -5546,6 +6042,7 @@
           <a:lstStyle/>
           <a:p>
             <a:pPr algn="ctr"/>
+            <a:endParaRPr/>
           </a:p>
         </p:txBody>
       </p:sp>
@@ -5657,6 +6154,7 @@
           <a:lstStyle/>
           <a:p>
             <a:pPr algn="ctr"/>
+            <a:endParaRPr/>
           </a:p>
         </p:txBody>
       </p:sp>

</xml_diff>